<commit_message>
Update Create Custom Task
</commit_message>
<xml_diff>
--- a/4. Creating Custom Implementation of Task/CreatingTaskFromScratch.pptx
+++ b/4. Creating Custom Implementation of Task/CreatingTaskFromScratch.pptx
@@ -7,10 +7,10 @@
     <p:sldMasterId id="2147484523" r:id="rId6"/>
   </p:sldMasterIdLst>
   <p:notesMasterIdLst>
-    <p:notesMasterId r:id="rId22"/>
+    <p:notesMasterId r:id="rId21"/>
   </p:notesMasterIdLst>
   <p:handoutMasterIdLst>
-    <p:handoutMasterId r:id="rId23"/>
+    <p:handoutMasterId r:id="rId22"/>
   </p:handoutMasterIdLst>
   <p:sldIdLst>
     <p:sldId id="276" r:id="rId7"/>
@@ -25,9 +25,8 @@
     <p:sldId id="286" r:id="rId16"/>
     <p:sldId id="287" r:id="rId17"/>
     <p:sldId id="288" r:id="rId18"/>
-    <p:sldId id="289" r:id="rId19"/>
-    <p:sldId id="293" r:id="rId20"/>
-    <p:sldId id="294" r:id="rId21"/>
+    <p:sldId id="293" r:id="rId19"/>
+    <p:sldId id="294" r:id="rId20"/>
   </p:sldIdLst>
   <p:sldSz cx="12436475" cy="6994525"/>
   <p:notesSz cx="6858000" cy="9144000"/>
@@ -255,7 +254,7 @@
               <a:rPr lang="en-US" smtClean="0">
                 <a:latin typeface="Segoe UI" pitchFamily="34" charset="0"/>
               </a:rPr>
-              <a:t>9/13/26 8:56 PM</a:t>
+              <a:t>9/14/26 5:55 AM</a:t>
             </a:fld>
             <a:endParaRPr lang="en-US">
               <a:latin typeface="Segoe UI" pitchFamily="34" charset="0"/>
@@ -533,7 +532,7 @@
           <a:p>
             <a:fld id="{D18B56EA-E28F-4F92-9F16-7A6F2501B303}" type="datetime8">
               <a:rPr lang="en-US" smtClean="0"/>
-              <a:t>9/13/26 8:56 PM</a:t>
+              <a:t>9/14/26 5:54 AM</a:t>
             </a:fld>
             <a:endParaRPr lang="en-US"/>
           </a:p>
@@ -831,7 +830,7 @@
           </a:p>
           <a:p>
             <a:r>
-              <a:t>Now we put all of it to work. Over the next twenty minutes you will meet every building block a Task is made of: a work queue, a completion flag, a list of callbacks, a lock, a way to store an exception, a blocking wait, a timer, and the small pattern the compiler looks for when it sees the await keyword. Then you open an empty class called CustomTask and assemble them yourself.</a:t>
+              <a:t>Now we put all of it to work. Over the next twenty minutes you will meet every building block a Task is made of: a work queue, a completion flag, a list of callbacks, a lock, a way to store an exception, a blocking wait, a timer, and the small pattern the compiler looks for when it sees the await keyword. Then you open a CustomTask class whose members are only stubs and fill them in yourself.</a:t>
             </a:r>
           </a:p>
           <a:p>
@@ -839,7 +838,7 @@
           </a:p>
           <a:p>
             <a:r>
-              <a:t>Two files are already written for you in the starter project. CustomTaskAwaiter.cs is complete: it is the bridge between await and your class, and we read it together near the end of this deck. Program.cs is also complete: it already awaits CustomTask.Run() and CustomTask.Delay(), which is why the starter does not compile yet. The compiler errors are the challenge's to-do list.</a:t>
+              <a:t>Two files are already written for you in the starter project. CustomTaskAwaiter.cs is complete: it is the bridge between await and your class, and we read it together near the end of this deck. Program.cs is also complete: it calls every public member of CustomTask, and the starter still compiles because CustomTask.cs declares each of those members as a stub that throws NotImplementedException. Run it, and each exception message is a hint about what that member needs to do. The stubs are the challenge's to-do list.</a:t>
             </a:r>
           </a:p>
           <a:p>
@@ -1218,7 +1217,7 @@
           </a:p>
           <a:p>
             <a:r>
-              <a:t>Why this matters for the challenge: the moment CustomTask exposes GetAwaiter(), the top-level await statements in Program.cs compile with no changes to the compiler, no attributes and no registration.</a:t>
+              <a:t>Why this matters for the challenge: because the starter's CustomTask already declares GetAwaiter(), the top-level await statements in Program.cs compile from the start with no changes to the compiler, no attributes and no registration. They start working the moment your GetAwaiter() returns a real CustomTaskAwaiter.</a:t>
             </a:r>
           </a:p>
           <a:p>
@@ -1301,7 +1300,7 @@
           <a:lstStyle/>
           <a:p>
             <a:r>
-              <a:t>Here is the whole pattern, and it is small.</a:t>
+              <a:t>Time to switch from listening to typing.</a:t>
             </a:r>
           </a:p>
           <a:p>
@@ -1309,27 +1308,7 @@
           </a:p>
           <a:p>
             <a:r>
-              <a:t>Bullet by bullet:</a:t>
-            </a:r>
-          </a:p>
-          <a:p>
-            <a:r>
-              <a:t>• GetAwaiter() on the awaited type: an instance method, or an extension method, with no parameters. Its return type is the awaiter.</a:t>
-            </a:r>
-          </a:p>
-          <a:p>
-            <a:r>
-              <a:t>• Awaiter: IsCompleted, OnCompleted(), GetResult(): a bool property, a void method taking an Action, and a method returning void or the result. The compiler duck-types these three members. IsCompleted answers "can I keep going right now?". OnCompleted(continuation) registers the rest of the method. GetResult() returns void or the result, and rethrows if the operation faulted.</a:t>
-            </a:r>
-          </a:p>
-          <a:p>
-            <a:r>
-              <a:t>• Only OnCompleted() comes from an interface: the awaiter type must implement INotifyCompletion from System.Runtime.CompilerServices; IsCompleted and GetResult() are found by name. The interface is on the slide in full: one method.</a:t>
-            </a:r>
-          </a:p>
-          <a:p>
-            <a:r>
-              <a:t>• UnsafeOnCompleted() is an optional extra: it comes from ICriticalNotifyCompletion, which derives from INotifyCompletion, and it is the no-ExecutionContext-flow version. When an awaiter implements it, the compiler-generated code prefers it, because the async method builder already captures and restores ExecutionContext for the state machine, so the awaiter does not need to do it again. You do not need it for this challenge.</a:t>
+              <a:t>Before you open the IDE, say back to yourself what a Task is: a completion flag, a stored exception, a list of continuations, and a lock around all three. Everything you are about to write is a method that reads or writes that state.</a:t>
             </a:r>
           </a:p>
           <a:p>
@@ -1337,7 +1316,7 @@
           </a:p>
           <a:p>
             <a:r>
-              <a:t>Notice what is not in the pattern: nothing about threads, schedulers or Task. A readonly struct with three one-line members satisfies it, which is exactly what the next slide shows.</a:t>
+              <a:t>Build up to it in stages. The starter builds from the first minute, because every public member is already a stub, but running it stops at the first stub you have not replaced yet. Start with the fields and the shared completion method. Add ContinueWith(), because Wait() and the awaiter both register through it. Then Wait(), then Run(), then Delay(), then GetAwaiter(). At that point no stubs remain, and Program.cs runs all five steps as written.</a:t>
             </a:r>
           </a:p>
           <a:p>
@@ -1345,7 +1324,7 @@
           </a:p>
           <a:p>
             <a:r>
-              <a:t>Why this matters for the challenge: requirement 10 is this slide. The awaiter is written for you; understanding why those three members exist tells you what CustomTask has to provide.</a:t>
+              <a:t>Test as you go, in temporary code at the bottom of Program.cs that you delete before comparing with 2. Finish. Chain two ContinueWith() calls, then Wait() on the task the second one returned; if that Wait() never returns, the returned task is never being completed. For two waiters, and for the several-thousand-link chain, build the chain on top of CustomTask.Delay(TimeSpan.FromSeconds(1)) so nothing has completed while you are still registering. Starting from an already completed task makes the test depend on how fast the pool drains the chain behind you, and a stack overflow you cannot reproduce is worse than one you can.</a:t>
             </a:r>
           </a:p>
           <a:p>
@@ -1353,17 +1332,25 @@
           </a:p>
           <a:p>
             <a:r>
+              <a:t>Use the .NET source when you get stuck. Task.cs and TaskAwaiter.cs are the reference implementation of what you are building, and the System.Runtime.ExceptionServices using at the top of the starter CustomTask.cs is a hint.</a:t>
+            </a:r>
+          </a:p>
+          <a:p>
+            <a:endParaRPr/>
+          </a:p>
+          <a:p>
+            <a:r>
               <a:t>References:</a:t>
             </a:r>
           </a:p>
           <a:p>
             <a:r>
-              <a:t>https://github.com/dotnet/runtime/blob/main/src/libraries/System.Private.CoreLib/src/System/Runtime/CompilerServices/INotifyCompletion.cs</a:t>
-            </a:r>
-          </a:p>
-          <a:p>
-            <a:r>
-              <a:t>https://learn.microsoft.com/dotnet/csharp/language-reference/operators/await</a:t>
+              <a:t>https://github.com/dotnet/runtime/blob/main/src/libraries/System.Private.CoreLib/src/System/Threading/Tasks/Task.cs</a:t>
+            </a:r>
+          </a:p>
+          <a:p>
+            <a:r>
+              <a:t>https://github.com/dotnet/runtime/blob/main/src/libraries/System.Private.CoreLib/src/System/Runtime/CompilerServices/TaskAwaiter.cs</a:t>
             </a:r>
           </a:p>
         </p:txBody>
@@ -1433,7 +1420,7 @@
           <a:lstStyle/>
           <a:p>
             <a:r>
-              <a:t>Time to switch from listening to typing.</a:t>
+              <a:t>Forty-five minutes, with the afternoon break in the middle. Open 4. Creating Custom Implementation of Task/1. Start/CreatingTaskFromScratch.slnx and run it once. It builds, but it stops at the first NotImplementedException, and that is expected: every public member of CustomTask is already a stub, and each stub's message is a hint about what that member needs to do.</a:t>
             </a:r>
           </a:p>
           <a:p>
@@ -1441,7 +1428,7 @@
           </a:p>
           <a:p>
             <a:r>
-              <a:t>Before you open the IDE, say back to yourself what a Task is: a completion flag, a stored exception, a list of continuations, and a lock around all three. Everything you are about to write is a method that reads or writes that state.</a:t>
+              <a:t>Two files are already finished. CustomTaskAwaiter.cs is the bridge from the previous slides; read it, do not edit it. Program.cs already calls every public member of CustomTask in five numbered steps, and its comments explain what each member should do. Use it as your guide: it is what you are building towards, so finish with it exactly as you found it. Temporary test code at the bottom of it while you work is fine and expected; delete it before you compare with 2. Finish. Everything else you write goes in CustomTask.cs.</a:t>
             </a:r>
           </a:p>
           <a:p>
@@ -1449,7 +1436,7 @@
           </a:p>
           <a:p>
             <a:r>
-              <a:t>Build up to it in stages, and expect no build at all until the last one: every file in the starter references members you have not written yet. Start with the fields and the shared completion method. Add ContinueWith(), because Wait() and the awaiter both register through it. Then Wait(), then Run(), then Delay(), then GetAwaiter(). At that point Program.cs compiles as written and you can run it.</a:t>
+              <a:t>You are building Run(Action), ContinueWith(Action), Wait(), Delay(TimeSpan), IsCompleted, SetResult(), SetException() and GetAwaiter(), plus the completion state underneath them: a lock, a completed flag, a stored exception, and a list of continuations with their captured ExecutionContext.</a:t>
             </a:r>
           </a:p>
           <a:p>
@@ -1457,127 +1444,7 @@
           </a:p>
           <a:p>
             <a:r>
-              <a:t>Test as you go, in temporary code at the bottom of Program.cs that you delete before comparing with 2. Finish. Chain two ContinueWith() calls, then Wait() on the task the second one returned; if that Wait() never returns, the returned task is never being completed. For two waiters, and for the several-thousand-link chain, build the chain on top of CustomTask.Delay(TimeSpan.FromSeconds(1)) so nothing has completed while you are still registering. Starting from an already completed task makes the test depend on how fast the pool drains the chain behind you, and a stack overflow you cannot reproduce is worse than one you can.</a:t>
-            </a:r>
-          </a:p>
-          <a:p>
-            <a:endParaRPr/>
-          </a:p>
-          <a:p>
-            <a:r>
-              <a:t>Use the .NET source when you get stuck. Task.cs and TaskAwaiter.cs are the reference implementation of what you are building, and the System.Runtime.ExceptionServices using at the top of the starter CustomTask.cs is a hint.</a:t>
-            </a:r>
-          </a:p>
-          <a:p>
-            <a:endParaRPr/>
-          </a:p>
-          <a:p>
-            <a:r>
-              <a:t>References:</a:t>
-            </a:r>
-          </a:p>
-          <a:p>
-            <a:r>
-              <a:t>https://github.com/dotnet/runtime/blob/main/src/libraries/System.Private.CoreLib/src/System/Threading/Tasks/Task.cs</a:t>
-            </a:r>
-          </a:p>
-          <a:p>
-            <a:r>
-              <a:t>https://github.com/dotnet/runtime/blob/main/src/libraries/System.Private.CoreLib/src/System/Runtime/CompilerServices/TaskAwaiter.cs</a:t>
-            </a:r>
-          </a:p>
-        </p:txBody>
-      </p:sp>
-      <p:sp>
-        <p:nvSpPr>
-          <p:cNvPr id="4" name="Slide Number Placeholder 3"/>
-          <p:cNvSpPr>
-            <a:spLocks noGrp="1"/>
-          </p:cNvSpPr>
-          <p:nvPr>
-            <p:ph type="sldNum" sz="quarter" idx="5"/>
-          </p:nvPr>
-        </p:nvSpPr>
-        <p:spPr/>
-      </p:sp>
-    </p:spTree>
-  </p:cSld>
-  <p:clrMapOvr>
-    <a:masterClrMapping/>
-  </p:clrMapOvr>
-</p:notes>
-</file>
-
-<file path=ppt/notesSlides/notesSlide15.xml><?xml version="1.0" encoding="utf-8"?>
-<p:notes xmlns:a="http://schemas.openxmlformats.org/drawingml/2006/main" xmlns:r="http://schemas.openxmlformats.org/officeDocument/2006/relationships" xmlns:p="http://schemas.openxmlformats.org/presentationml/2006/main">
-  <p:cSld>
-    <p:spTree>
-      <p:nvGrpSpPr>
-        <p:cNvPr id="1" name=""/>
-        <p:cNvGrpSpPr/>
-        <p:nvPr/>
-      </p:nvGrpSpPr>
-      <p:grpSpPr>
-        <a:xfrm>
-          <a:off x="0" y="0"/>
-          <a:ext cx="0" cy="0"/>
-          <a:chOff x="0" y="0"/>
-          <a:chExt cx="0" cy="0"/>
-        </a:xfrm>
-      </p:grpSpPr>
-      <p:sp>
-        <p:nvSpPr>
-          <p:cNvPr id="2" name="Slide Image Placeholder 1"/>
-          <p:cNvSpPr>
-            <a:spLocks noGrp="1" noRot="1" noChangeAspect="1"/>
-          </p:cNvSpPr>
-          <p:nvPr>
-            <p:ph type="sldImg" idx="2"/>
-          </p:nvPr>
-        </p:nvSpPr>
-        <p:spPr/>
-      </p:sp>
-      <p:sp>
-        <p:nvSpPr>
-          <p:cNvPr id="3" name="Notes Placeholder 2"/>
-          <p:cNvSpPr>
-            <a:spLocks noGrp="1"/>
-          </p:cNvSpPr>
-          <p:nvPr>
-            <p:ph type="body" sz="quarter" idx="3"/>
-          </p:nvPr>
-        </p:nvSpPr>
-        <p:spPr/>
-        <p:txBody>
-          <a:bodyPr/>
-          <a:lstStyle/>
-          <a:p>
-            <a:r>
-              <a:t>Forty-five minutes, with the afternoon break in the middle. Open 4. Creating Custom Implementation of Task/1. Start/CreatingTaskFromScratch.slnx and build it once. It fails, and that is expected: every error names a CustomTask member that does not exist yet.</a:t>
-            </a:r>
-          </a:p>
-          <a:p>
-            <a:endParaRPr/>
-          </a:p>
-          <a:p>
-            <a:r>
-              <a:t>Two files are already finished. CustomTaskAwaiter.cs is the bridge from the previous slides; read it, do not edit it. Program.cs already awaits CustomTask.Run() and CustomTask.Delay() and prints the four thread Ids, and it is what you are building towards, so finish with it exactly as you found it. Temporary test code at the bottom of it while you work is fine and expected; delete it before you compare with 2. Finish. Everything else you write goes in CustomTask.cs.</a:t>
-            </a:r>
-          </a:p>
-          <a:p>
-            <a:endParaRPr/>
-          </a:p>
-          <a:p>
-            <a:r>
-              <a:t>You are building Run(Action), ContinueWith(Action), Wait(), Delay(TimeSpan), IsCompleted and GetAwaiter(), plus the completion state underneath them: a lock, a completed flag, a stored exception, and a list of continuations with their captured ExecutionContext.</a:t>
-            </a:r>
-          </a:p>
-          <a:p>
-            <a:endParaRPr/>
-          </a:p>
-          <a:p>
-            <a:r>
-              <a:t>You are done when the solution builds and prints the Starting Thread Id and three CustomTask Ids, a continuation runs after the first task completes, chaining ContinueWith() on the task returned by ContinueWith() does not wait forever, two callers waiting on the same incomplete task both resume, and a chain of several thousand ContinueWith() calls finishes without a stack overflow.</a:t>
+              <a:t>You are done when the solution builds and Program.cs runs all five steps with the output its comments describe, a continuation runs after the first task completes, chaining ContinueWith() on the task returned by ContinueWith() does not wait forever, two callers waiting on the same incomplete task both resume, and a chain of several thousand ContinueWith() calls finishes without a stack overflow.</a:t>
             </a:r>
           </a:p>
           <a:p>
@@ -1920,7 +1787,7 @@
           </a:p>
           <a:p>
             <a:r>
-              <a:t>Why this matters for the challenge: requirement 3 is Run(Action) on the Thread Pool, and acceptance check 2, "three CustomTask thread Ids", is the visible proof that the work left the starting thread.</a:t>
+              <a:t>Why this matters for the challenge: requirement 3 is Run(Action) on the Thread Pool, and acceptance check 2 runs Step 1 of Program.cs, where the Run() action prints a thread pool Thread Id instead of the main thread's: the visible proof that the work left the starting thread.</a:t>
             </a:r>
           </a:p>
           <a:p>
@@ -2300,7 +2167,7 @@
           </a:p>
           <a:p>
             <a:r>
-              <a:t>Why this matters for the challenge: requirements 1, 2 and 5 all meet in this one method, and it is the method the next three slides keep pointing back to.</a:t>
+              <a:t>Why this matters for the challenge: requirements 1, 2, 5 and 11 all meet in this one method, and it is the method the next three slides keep pointing back to.</a:t>
             </a:r>
           </a:p>
           <a:p>
@@ -8735,7 +8602,7 @@
         <p:spPr>
           <a:xfrm>
             <a:off x="274320" y="1627632"/>
-            <a:ext cx="5303520" cy="4636008"/>
+            <a:ext cx="10816814" cy="4636008"/>
           </a:xfrm>
         </p:spPr>
         <p:txBody>
@@ -8783,8 +8650,8 @@
         </p:blipFill>
         <p:spPr>
           <a:xfrm>
-            <a:off x="5577839" y="2255697"/>
-            <a:ext cx="6583680" cy="3215286"/>
+            <a:off x="6218237" y="3809704"/>
+            <a:ext cx="5943918" cy="2902844"/>
           </a:xfrm>
           <a:prstGeom prst="rect">
             <a:avLst/>
@@ -8882,8 +8749,8 @@
         </p:nvSpPr>
         <p:spPr>
           <a:xfrm>
-            <a:off x="274320" y="1627632"/>
-            <a:ext cx="5303520" cy="4636008"/>
+            <a:off x="274319" y="1627632"/>
+            <a:ext cx="9009529" cy="4636008"/>
           </a:xfrm>
         </p:spPr>
         <p:txBody>
@@ -8931,7 +8798,7 @@
         </p:blipFill>
         <p:spPr>
           <a:xfrm>
-            <a:off x="5577839" y="2542410"/>
+            <a:off x="5222837" y="3945636"/>
             <a:ext cx="6583680" cy="2641859"/>
           </a:xfrm>
           <a:prstGeom prst="rect">
@@ -8973,7 +8840,7 @@
         <p:spPr>
           <a:xfrm>
             <a:off x="658368" y="2011680"/>
-            <a:ext cx="11155680" cy="1371600"/>
+            <a:ext cx="11155680" cy="1107996"/>
           </a:xfrm>
           <a:prstGeom prst="rect">
             <a:avLst/>
@@ -9001,7 +8868,7 @@
                 </a:gradFill>
                 <a:latin typeface="+mj-lt"/>
               </a:rPr>
-              <a:t>Await Is Just a Pattern</a:t>
+              <a:t>Await Uses Duck Typing</a:t>
             </a:r>
           </a:p>
         </p:txBody>
@@ -9014,7 +8881,7 @@
         </p:nvSpPr>
         <p:spPr>
           <a:xfrm>
-            <a:off x="768096" y="4023360"/>
+            <a:off x="886430" y="3582297"/>
             <a:ext cx="11155680" cy="914400"/>
           </a:xfrm>
           <a:prstGeom prst="rect">
@@ -9037,6 +8904,68 @@
               </a:rPr>
               <a:t>Any Type With GetAwaiter() Can Be Awaited</a:t>
             </a:r>
+          </a:p>
+        </p:txBody>
+      </p:sp>
+      <p:sp>
+        <p:nvSpPr>
+          <p:cNvPr id="9" name="TextBox 8">
+            <a:extLst>
+              <a:ext uri="{FF2B5EF4-FFF2-40B4-BE49-F238E27FC236}">
+                <a16:creationId xmlns:a16="http://schemas.microsoft.com/office/drawing/2014/main" id="{48BE70F8-DE91-7813-7218-C48E84A30973}"/>
+              </a:ext>
+            </a:extLst>
+          </p:cNvPr>
+          <p:cNvSpPr txBox="1"/>
+          <p:nvPr/>
+        </p:nvSpPr>
+        <p:spPr>
+          <a:xfrm>
+            <a:off x="886430" y="5463099"/>
+            <a:ext cx="8498541" cy="523220"/>
+          </a:xfrm>
+          <a:prstGeom prst="rect">
+            <a:avLst/>
+          </a:prstGeom>
+          <a:noFill/>
+        </p:spPr>
+        <p:txBody>
+          <a:bodyPr wrap="square">
+            <a:spAutoFit/>
+          </a:bodyPr>
+          <a:lstStyle/>
+          <a:p>
+            <a:r>
+              <a:rPr lang="en-US" b="0" i="1" u="none" strike="noStrike" dirty="0">
+                <a:solidFill>
+                  <a:schemeClr val="tx1"/>
+                </a:solidFill>
+                <a:effectLst/>
+                <a:latin typeface="+mn-lt"/>
+              </a:rPr>
+              <a:t>If it walks like a duck and it quacks like a duck, </a:t>
+            </a:r>
+            <a:r>
+              <a:rPr lang="en-US" sz="2800" b="0" i="1" u="none" strike="noStrike" dirty="0">
+                <a:solidFill>
+                  <a:schemeClr val="tx1"/>
+                </a:solidFill>
+                <a:effectLst/>
+                <a:latin typeface="+mn-lt"/>
+              </a:rPr>
+              <a:t>then</a:t>
+            </a:r>
+            <a:r>
+              <a:rPr lang="en-US" b="0" i="1" u="none" strike="noStrike" dirty="0">
+                <a:solidFill>
+                  <a:schemeClr val="tx1"/>
+                </a:solidFill>
+                <a:effectLst/>
+                <a:latin typeface="+mn-lt"/>
+              </a:rPr>
+              <a:t> it must be a duck.</a:t>
+            </a:r>
+            <a:endParaRPr lang="en-US" i="1" dirty="0"/>
           </a:p>
         </p:txBody>
       </p:sp>
@@ -9082,112 +9011,11 @@
           <a:p>
             <a:r>
               <a:rPr lang="en-US" dirty="0"/>
-              <a:t>Awaiter Pattern</a:t>
-            </a:r>
-            <a:br>
-              <a:rPr lang="en-US" dirty="0"/>
-            </a:br>
-            <a:r>
-              <a:rPr lang="en-US" sz="3600" dirty="0">
-                <a:gradFill>
-                  <a:gsLst>
-                    <a:gs pos="1250">
-                      <a:srgbClr val="FFB900"/>
-                    </a:gs>
-                    <a:gs pos="100000">
-                      <a:srgbClr val="FFB900"/>
-                    </a:gs>
-                  </a:gsLst>
-                  <a:lin ang="5400000" scaled="0"/>
-                </a:gradFill>
-              </a:rPr>
-              <a:t>INotifyCompletion</a:t>
-            </a:r>
-            <a:endParaRPr lang="en-US" sz="4000" dirty="0">
-              <a:gradFill>
-                <a:gsLst>
-                  <a:gs pos="1250">
-                    <a:srgbClr val="FFB900"/>
-                  </a:gs>
-                  <a:gs pos="100000">
-                    <a:srgbClr val="FFB900"/>
-                  </a:gs>
-                </a:gsLst>
-                <a:lin ang="5400000" scaled="0"/>
-              </a:gradFill>
-            </a:endParaRPr>
+              <a:t>Let's Build a Task</a:t>
+            </a:r>
           </a:p>
         </p:txBody>
       </p:sp>
-      <p:sp>
-        <p:nvSpPr>
-          <p:cNvPr id="3" name="Text Placeholder 2"/>
-          <p:cNvSpPr>
-            <a:spLocks noGrp="1"/>
-          </p:cNvSpPr>
-          <p:nvPr>
-            <p:ph type="body" sz="quarter" idx="10"/>
-          </p:nvPr>
-        </p:nvSpPr>
-        <p:spPr>
-          <a:xfrm>
-            <a:off x="274320" y="1627632"/>
-            <a:ext cx="5303520" cy="4636008"/>
-          </a:xfrm>
-        </p:spPr>
-        <p:txBody>
-          <a:bodyPr/>
-          <a:lstStyle/>
-          <a:p>
-            <a:r>
-              <a:rPr lang="en-US" sz="2800" dirty="0"/>
-              <a:t>`GetAwaiter()` on the awaited type</a:t>
-            </a:r>
-          </a:p>
-          <a:p>
-            <a:r>
-              <a:rPr lang="en-US" sz="2800" dirty="0"/>
-              <a:t>Awaiter: `IsCompleted`, `OnCompleted()`, `GetResult()`</a:t>
-            </a:r>
-          </a:p>
-          <a:p>
-            <a:r>
-              <a:rPr lang="en-US" sz="2800" dirty="0"/>
-              <a:t>Only `OnCompleted()` comes from an interface</a:t>
-            </a:r>
-          </a:p>
-          <a:p>
-            <a:r>
-              <a:rPr lang="en-US" sz="2800" dirty="0"/>
-              <a:t>`UnsafeOnCompleted()` is an optional extra</a:t>
-            </a:r>
-          </a:p>
-        </p:txBody>
-      </p:sp>
-      <p:pic>
-        <p:nvPicPr>
-          <p:cNvPr id="4" name="Picture 3" descr="slide14.png"/>
-          <p:cNvPicPr>
-            <a:picLocks noChangeAspect="1"/>
-          </p:cNvPicPr>
-          <p:nvPr/>
-        </p:nvPicPr>
-        <p:blipFill>
-          <a:blip r:embed="rId3"/>
-          <a:stretch>
-            <a:fillRect/>
-          </a:stretch>
-        </p:blipFill>
-        <p:spPr>
-          <a:xfrm>
-            <a:off x="5577839" y="1459558"/>
-            <a:ext cx="6583680" cy="4807563"/>
-          </a:xfrm>
-          <a:prstGeom prst="rect">
-            <a:avLst/>
-          </a:prstGeom>
-        </p:spPr>
-      </p:pic>
     </p:spTree>
   </p:cSld>
   <p:clrMapOvr>
@@ -9230,53 +9058,6 @@
           <a:p>
             <a:r>
               <a:rPr lang="en-US" dirty="0"/>
-              <a:t>Let's Build a Task</a:t>
-            </a:r>
-          </a:p>
-        </p:txBody>
-      </p:sp>
-    </p:spTree>
-  </p:cSld>
-  <p:clrMapOvr>
-    <a:masterClrMapping/>
-  </p:clrMapOvr>
-</p:sld>
-</file>
-
-<file path=ppt/slides/slide15.xml><?xml version="1.0" encoding="utf-8"?>
-<p:sld xmlns:a="http://schemas.openxmlformats.org/drawingml/2006/main" xmlns:r="http://schemas.openxmlformats.org/officeDocument/2006/relationships" xmlns:p="http://schemas.openxmlformats.org/presentationml/2006/main">
-  <p:cSld>
-    <p:spTree>
-      <p:nvGrpSpPr>
-        <p:cNvPr id="1" name=""/>
-        <p:cNvGrpSpPr/>
-        <p:nvPr/>
-      </p:nvGrpSpPr>
-      <p:grpSpPr>
-        <a:xfrm>
-          <a:off x="0" y="0"/>
-          <a:ext cx="0" cy="0"/>
-          <a:chOff x="0" y="0"/>
-          <a:chExt cx="0" cy="0"/>
-        </a:xfrm>
-      </p:grpSpPr>
-      <p:sp>
-        <p:nvSpPr>
-          <p:cNvPr id="2" name="Title 1"/>
-          <p:cNvSpPr>
-            <a:spLocks noGrp="1"/>
-          </p:cNvSpPr>
-          <p:nvPr>
-            <p:ph type="title"/>
-          </p:nvPr>
-        </p:nvSpPr>
-        <p:spPr/>
-        <p:txBody>
-          <a:bodyPr/>
-          <a:lstStyle/>
-          <a:p>
-            <a:r>
-              <a:rPr lang="en-US" dirty="0"/>
               <a:t>Challenge: Build an Awaitable CustomTask</a:t>
             </a:r>
             <a:br>
@@ -9327,7 +9108,7 @@
         <p:spPr>
           <a:xfrm>
             <a:off x="274320" y="1627632"/>
-            <a:ext cx="11887200" cy="4636008"/>
+            <a:ext cx="11887200" cy="3594830"/>
           </a:xfrm>
         </p:spPr>
         <p:txBody>
@@ -9343,14 +9124,14 @@
             <a:pPr lvl="1"/>
             <a:r>
               <a:rPr lang="en-US" dirty="0"/>
-              <a:t>Provided: `CustomTaskAwaiter.cs` and `Program.cs`</a:t>
+              <a:t>Provided: `CustomTaskAwaiter.cs`, `Program.cs`, `CustomTask` stubs</a:t>
             </a:r>
           </a:p>
           <a:p>
             <a:pPr lvl="1"/>
             <a:r>
               <a:rPr lang="en-US" dirty="0"/>
-              <a:t>Prints the Starting Thread Id and three `CustomTask` Ids</a:t>
+              <a:t>`Program.cs` runs all five steps, as its comments describe</a:t>
             </a:r>
           </a:p>
           <a:p>
@@ -9370,14 +9151,14 @@
           <a:p>
             <a:r>
               <a:rPr lang="en-US" dirty="0"/>
-              <a:t>AI Agents: understand, interpret errors, ask questions*</a:t>
+              <a:t>AI Agents: understand, interpret errors, ask questions</a:t>
             </a:r>
           </a:p>
           <a:p>
             <a:pPr lvl="2"/>
             <a:r>
               <a:rPr lang="en-US" dirty="0"/>
-              <a:t>*Not to solve the challenge. You're smart. You got this.</a:t>
+              <a:t>Not to solve the challenge. You're smart. You got this.</a:t>
             </a:r>
           </a:p>
         </p:txBody>
@@ -10455,7 +10236,7 @@
         <p:spPr>
           <a:xfrm>
             <a:off x="274320" y="1627632"/>
-            <a:ext cx="5303520" cy="4636008"/>
+            <a:ext cx="9493624" cy="2536079"/>
           </a:xfrm>
         </p:spPr>
         <p:txBody>
@@ -10476,14 +10257,23 @@
           <a:p>
             <a:r>
               <a:rPr lang="en-US" sz="2800" dirty="0"/>
+              <a:t>Always use `ExceptionDispatchInfo` to preserve Stack Trace</a:t>
+            </a:r>
+          </a:p>
+          <a:p>
+            <a:pPr lvl="1"/>
+            <a:r>
+              <a:rPr lang="en-US" sz="2000" dirty="0"/>
               <a:t>`throw ex;` resets the stack trace</a:t>
             </a:r>
           </a:p>
           <a:p>
-            <a:r>
-              <a:rPr lang="en-US" sz="2800" dirty="0"/>
-              <a:t>`ExceptionDispatchInfo` preserves it</a:t>
-            </a:r>
+            <a:pPr lvl="1"/>
+            <a:endParaRPr lang="en-US" sz="2000" dirty="0"/>
+          </a:p>
+          <a:p>
+            <a:pPr lvl="1"/>
+            <a:endParaRPr lang="en-US" sz="2000" dirty="0"/>
           </a:p>
         </p:txBody>
       </p:sp>
@@ -10503,8 +10293,8 @@
         </p:blipFill>
         <p:spPr>
           <a:xfrm>
-            <a:off x="5577839" y="2178526"/>
-            <a:ext cx="6583680" cy="3369628"/>
+            <a:off x="6390042" y="3810892"/>
+            <a:ext cx="5771478" cy="2953931"/>
           </a:xfrm>
           <a:prstGeom prst="rect">
             <a:avLst/>
@@ -12238,6 +12028,15 @@
 </file>
 
 <file path=customXml/item2.xml><?xml version="1.0" encoding="utf-8"?>
+<?mso-contentType ?>
+<FormTemplates xmlns="http://schemas.microsoft.com/sharepoint/v3/contenttype/forms">
+  <Display>DocumentLibraryForm</Display>
+  <Edit>DocumentLibraryForm</Edit>
+  <New>DocumentLibraryForm</New>
+</FormTemplates>
+</file>
+
+<file path=customXml/item3.xml><?xml version="1.0" encoding="utf-8"?>
 <p:properties xmlns:p="http://schemas.microsoft.com/office/2006/metadata/properties" xmlns:xsi="http://www.w3.org/2001/XMLSchema-instance" xmlns:pc="http://schemas.microsoft.com/office/infopath/2007/PartnerControls">
   <documentManagement>
     <_ip_UnifiedCompliancePolicyUIAction xmlns="http://schemas.microsoft.com/sharepoint/v3" xsi:nil="true"/>
@@ -12245,15 +12044,6 @@
     <_ip_UnifiedCompliancePolicyProperties xmlns="http://schemas.microsoft.com/sharepoint/v3" xsi:nil="true"/>
   </documentManagement>
 </p:properties>
-</file>
-
-<file path=customXml/item3.xml><?xml version="1.0" encoding="utf-8"?>
-<?mso-contentType ?>
-<FormTemplates xmlns="http://schemas.microsoft.com/sharepoint/v3/contenttype/forms">
-  <Display>DocumentLibraryForm</Display>
-  <Edit>DocumentLibraryForm</Edit>
-  <New>DocumentLibraryForm</New>
-</FormTemplates>
 </file>
 
 <file path=customXml/itemProps1.xml><?xml version="1.0" encoding="utf-8"?>
@@ -12277,6 +12067,14 @@
 </file>
 
 <file path=customXml/itemProps2.xml><?xml version="1.0" encoding="utf-8"?>
+<ds:datastoreItem xmlns:ds="http://schemas.openxmlformats.org/officeDocument/2006/customXml" ds:itemID="{758FDAC0-319D-4A54-8D8E-1D42CB1F8004}">
+  <ds:schemaRefs>
+    <ds:schemaRef ds:uri="http://schemas.microsoft.com/sharepoint/v3/contenttype/forms"/>
+  </ds:schemaRefs>
+</ds:datastoreItem>
+</file>
+
+<file path=customXml/itemProps3.xml><?xml version="1.0" encoding="utf-8"?>
 <ds:datastoreItem xmlns:ds="http://schemas.openxmlformats.org/officeDocument/2006/customXml" ds:itemID="{B59C5458-A72E-4627-9FFC-D350DCB4700F}">
   <ds:schemaRefs>
     <ds:schemaRef ds:uri="http://schemas.microsoft.com/office/2006/metadata/properties"/>
@@ -12294,14 +12092,6 @@
 </ds:datastoreItem>
 </file>
 
-<file path=customXml/itemProps3.xml><?xml version="1.0" encoding="utf-8"?>
-<ds:datastoreItem xmlns:ds="http://schemas.openxmlformats.org/officeDocument/2006/customXml" ds:itemID="{758FDAC0-319D-4A54-8D8E-1D42CB1F8004}">
-  <ds:schemaRefs>
-    <ds:schemaRef ds:uri="http://schemas.microsoft.com/sharepoint/v3/contenttype/forms"/>
-  </ds:schemaRefs>
-</ds:datastoreItem>
-</file>
-
 <file path=docMetadata/LabelInfo.xml><?xml version="1.0" encoding="utf-8"?>
 <clbl:labelList xmlns:clbl="http://schemas.microsoft.com/office/2020/mipLabelMetadata">
   <clbl:label id="{f42aa342-8706-4288-bd11-ebb85995028c}" enabled="1" method="Privileged" siteId="{72f988bf-86f1-41af-91ab-2d7cd011db47}" removed="0"/>

</xml_diff>